<commit_message>
BUILD-SPEC-4 done: MCP slide (slide 5) + MCP-READY cover badge in all 4 decks, verified by Hermes M1-M6 (8 slides each, XML-verified, no em dashes, only deck files touched)
</commit_message>
<xml_diff>
--- a/scaffold/deck/deck-agentic.pptx
+++ b/scaffold/deck/deck-agentic.pptx
@@ -12,9 +12,10 @@
     <p:sldId id="260" r:id="rId6"/>
     <p:sldId id="261" r:id="rId7"/>
     <p:sldId id="262" r:id="rId8"/>
+    <p:sldId id="263" r:id="rId9"/>
   </p:sldIdLst>
   <p:notesMasterIdLst>
-    <p:notesMasterId r:id="rId9"/>
+    <p:notesMasterId r:id="rId10"/>
   </p:notesMasterIdLst>
   <p:sldSz cx="12188952" cy="6858000"/>
   <p:notesSz cx="6858000" cy="12188952"/>
@@ -860,7 +861,7 @@
           <a:p>
             <a:r>
               <a:rPr lang="en-US" dirty="0"/>
-              <a:t>Numbers are the hook: 1 feed replaces N channels; 10s to know what needs action; 0 actions missed after install</a:t>
+              <a:t>MCP is the wedge: approval-gated compose beats rebuild, gate outside the model.</a:t>
             </a:r>
             <a:endParaRPr lang="en-US" dirty="0"/>
           </a:p>
@@ -948,7 +949,7 @@
           <a:p>
             <a:r>
               <a:rPr lang="en-US" dirty="0"/>
-              <a:t>24h build tonight, roadmap after.</a:t>
+              <a:t>Numbers are the hook: 1 feed replaces N channels; 10s to know what needs action; 0 actions missed after install</a:t>
             </a:r>
             <a:endParaRPr lang="en-US" dirty="0"/>
           </a:p>
@@ -1036,7 +1037,7 @@
           <a:p>
             <a:r>
               <a:rPr lang="en-US" dirty="0"/>
-              <a:t>Keep it 20 seconds: names + roles + one line each.</a:t>
+              <a:t>24h build tonight, roadmap after.</a:t>
             </a:r>
             <a:endParaRPr lang="en-US" dirty="0"/>
           </a:p>
@@ -1060,6 +1061,94 @@
             <a:fld id="{F7021451-1387-4CA6-816F-3879F97B5CBC}" type="slidenum">
               <a:rPr lang="en-US"/>
               <a:t>7</a:t>
+            </a:fld>
+            <a:endParaRPr lang="en-US"/>
+          </a:p>
+        </p:txBody>
+      </p:sp>
+    </p:spTree>
+    <p:extLst>
+      <p:ext uri="{BB962C8B-B14F-4D97-AF65-F5344CB8AC3E}">
+        <p14:creationId xmlns:p14="http://schemas.microsoft.com/office/powerpoint/2010/main" val="1024086991"/>
+      </p:ext>
+    </p:extLst>
+  </p:cSld>
+  <p:clrMapOvr>
+    <a:masterClrMapping/>
+  </p:clrMapOvr>
+</p:notes>
+</file>
+
+<file path=ppt/notesSlides/notesSlide8.xml><?xml version="1.0" encoding="utf-8"?>
+<p:notes xmlns:a="http://schemas.openxmlformats.org/drawingml/2006/main" xmlns:r="http://schemas.openxmlformats.org/officeDocument/2006/relationships" xmlns:p="http://schemas.openxmlformats.org/presentationml/2006/main">
+  <p:cSld>
+    <p:spTree>
+      <p:nvGrpSpPr>
+        <p:cNvPr id="1" name=""/>
+        <p:cNvGrpSpPr/>
+        <p:nvPr/>
+      </p:nvGrpSpPr>
+      <p:grpSpPr>
+        <a:xfrm>
+          <a:off x="0" y="0"/>
+          <a:ext cx="0" cy="0"/>
+          <a:chOff x="0" y="0"/>
+          <a:chExt cx="0" cy="0"/>
+        </a:xfrm>
+      </p:grpSpPr>
+      <p:sp>
+        <p:nvSpPr>
+          <p:cNvPr id="2" name="Slide Image Placeholder 1"/>
+          <p:cNvSpPr>
+            <a:spLocks noGrp="1" noRot="1" noChangeAspect="1"/>
+          </p:cNvSpPr>
+          <p:nvPr>
+            <p:ph type="sldImg"/>
+          </p:nvPr>
+        </p:nvSpPr>
+        <p:spPr/>
+      </p:sp>
+      <p:sp>
+        <p:nvSpPr>
+          <p:cNvPr id="3" name="Notes Placeholder 2"/>
+          <p:cNvSpPr>
+            <a:spLocks noGrp="1"/>
+          </p:cNvSpPr>
+          <p:nvPr>
+            <p:ph type="body" idx="1"/>
+          </p:nvPr>
+        </p:nvSpPr>
+        <p:spPr/>
+        <p:txBody>
+          <a:bodyPr/>
+          <a:lstStyle/>
+          <a:p>
+            <a:r>
+              <a:rPr lang="en-US" dirty="0"/>
+              <a:t>Keep it 20 seconds: names + roles + one line each.</a:t>
+            </a:r>
+            <a:endParaRPr lang="en-US" dirty="0"/>
+          </a:p>
+        </p:txBody>
+      </p:sp>
+      <p:sp>
+        <p:nvSpPr>
+          <p:cNvPr id="4" name="Slide Number Placeholder 3"/>
+          <p:cNvSpPr>
+            <a:spLocks noGrp="1"/>
+          </p:cNvSpPr>
+          <p:nvPr>
+            <p:ph type="sldNum" sz="quarter" idx="10"/>
+          </p:nvPr>
+        </p:nvSpPr>
+        <p:spPr/>
+        <p:txBody>
+          <a:bodyPr/>
+          <a:lstStyle/>
+          <a:p>
+            <a:fld id="{F7021451-1387-4CA6-816F-3879F97B5CBC}" type="slidenum">
+              <a:rPr lang="en-US"/>
+              <a:t>8</a:t>
             </a:fld>
             <a:endParaRPr lang="en-US"/>
           </a:p>
@@ -1540,6 +1629,42 @@
           </a:p>
         </p:txBody>
       </p:sp>
+      <p:sp>
+        <p:nvSpPr>
+          <p:cNvPr id="6" name="Text 4"/>
+          <p:cNvSpPr/>
+          <p:nvPr/>
+        </p:nvSpPr>
+        <p:spPr>
+          <a:xfrm>
+            <a:off x="9692640" y="6446520"/>
+            <a:ext cx="1828800" cy="274320"/>
+          </a:xfrm>
+          <a:prstGeom prst="rect">
+            <a:avLst/>
+          </a:prstGeom>
+          <a:noFill/>
+          <a:ln/>
+        </p:spPr>
+        <p:txBody>
+          <a:bodyPr wrap="square" rtlCol="0" anchor="ctr"/>
+          <a:lstStyle/>
+          <a:p>
+            <a:pPr algn="r" indent="0" marL="0">
+              <a:buNone/>
+            </a:pPr>
+            <a:r>
+              <a:rPr lang="en-US" sz="1200" b="1" dirty="0">
+                <a:solidFill>
+                  <a:srgbClr val="6C5CE7"/>
+                </a:solidFill>
+              </a:rPr>
+              <a:t>MCP-READY</a:t>
+            </a:r>
+            <a:endParaRPr lang="en-US" sz="1200" dirty="0"/>
+          </a:p>
+        </p:txBody>
+      </p:sp>
     </p:spTree>
   </p:cSld>
   <p:clrMapOvr>
@@ -2574,14 +2699,34 @@
       </p:grpSpPr>
       <p:sp>
         <p:nvSpPr>
-          <p:cNvPr id="2" name="Text 0"/>
+          <p:cNvPr id="2" name="Shape 0"/>
+          <p:cNvSpPr/>
+          <p:nvPr/>
+        </p:nvSpPr>
+        <p:spPr>
+          <a:xfrm>
+            <a:off x="0" y="0"/>
+            <a:ext cx="12188952" cy="73152"/>
+          </a:xfrm>
+          <a:prstGeom prst="rect">
+            <a:avLst/>
+          </a:prstGeom>
+          <a:solidFill>
+            <a:srgbClr val="6C5CE7"/>
+          </a:solidFill>
+          <a:ln/>
+        </p:spPr>
+      </p:sp>
+      <p:sp>
+        <p:nvSpPr>
+          <p:cNvPr id="3" name="Text 1"/>
           <p:cNvSpPr/>
           <p:nvPr/>
         </p:nvSpPr>
         <p:spPr>
           <a:xfrm>
             <a:off x="822960" y="457200"/>
-            <a:ext cx="5486400" cy="548640"/>
+            <a:ext cx="10515600" cy="640080"/>
           </a:xfrm>
           <a:prstGeom prst="rect">
             <a:avLst/>
@@ -2597,88 +2742,43 @@
               <a:buNone/>
             </a:pPr>
             <a:r>
-              <a:rPr lang="en-US" sz="3000" b="1" dirty="0">
+              <a:rPr lang="en-US" sz="2600" b="1" dirty="0">
                 <a:solidFill>
                   <a:srgbClr val="FFFFFF"/>
                 </a:solidFill>
               </a:rPr>
-              <a:t>Impact</a:t>
-            </a:r>
-            <a:endParaRPr lang="en-US" sz="3000" dirty="0"/>
-          </a:p>
-        </p:txBody>
-      </p:sp>
-      <p:sp>
-        <p:nvSpPr>
-          <p:cNvPr id="3" name="Text 1"/>
-          <p:cNvSpPr/>
-          <p:nvPr/>
-        </p:nvSpPr>
-        <p:spPr>
-          <a:xfrm>
-            <a:off x="914400" y="2103120"/>
-            <a:ext cx="3108960" cy="1097280"/>
-          </a:xfrm>
-          <a:prstGeom prst="rect">
-            <a:avLst/>
-          </a:prstGeom>
-          <a:noFill/>
-          <a:ln/>
-        </p:spPr>
-        <p:txBody>
-          <a:bodyPr wrap="square" rtlCol="0" anchor="ctr"/>
-          <a:lstStyle/>
-          <a:p>
-            <a:pPr algn="ctr" indent="0" marL="0">
-              <a:buNone/>
-            </a:pPr>
-            <a:r>
-              <a:rPr lang="en-US" sz="4400" b="1" dirty="0">
-                <a:solidFill>
-                  <a:srgbClr val="6C5CE7"/>
-                </a:solidFill>
-              </a:rPr>
-              <a:t>1</a:t>
-            </a:r>
-            <a:endParaRPr lang="en-US" sz="4400" dirty="0"/>
-          </a:p>
-        </p:txBody>
-      </p:sp>
-      <p:sp>
-        <p:nvSpPr>
-          <p:cNvPr id="4" name="Text 2"/>
-          <p:cNvSpPr/>
-          <p:nvPr/>
-        </p:nvSpPr>
-        <p:spPr>
-          <a:xfrm>
-            <a:off x="914400" y="3383280"/>
-            <a:ext cx="3108960" cy="1097280"/>
-          </a:xfrm>
-          <a:prstGeom prst="rect">
-            <a:avLst/>
-          </a:prstGeom>
-          <a:noFill/>
-          <a:ln/>
-        </p:spPr>
-        <p:txBody>
-          <a:bodyPr wrap="square" rtlCol="0" anchor="ctr"/>
-          <a:lstStyle/>
-          <a:p>
-            <a:pPr algn="ctr" indent="0" marL="0">
-              <a:buNone/>
-            </a:pPr>
-            <a:r>
-              <a:rPr lang="en-US" sz="1400" dirty="0">
-                <a:solidFill>
-                  <a:srgbClr val="93A0C4"/>
-                </a:solidFill>
-              </a:rPr>
-              <a:t>feed replaces N channels</a:t>
-            </a:r>
-            <a:endParaRPr lang="en-US" sz="1400" dirty="0"/>
-          </a:p>
-        </p:txBody>
+              <a:t>MCP: capabilities behind a gate you approve</a:t>
+            </a:r>
+            <a:endParaRPr lang="en-US" sz="2600" dirty="0"/>
+          </a:p>
+        </p:txBody>
+      </p:sp>
+      <p:sp>
+        <p:nvSpPr>
+          <p:cNvPr id="4" name="Shape 2"/>
+          <p:cNvSpPr/>
+          <p:nvPr/>
+        </p:nvSpPr>
+        <p:spPr>
+          <a:xfrm>
+            <a:off x="822960" y="1554480"/>
+            <a:ext cx="10515600" cy="960120"/>
+          </a:xfrm>
+          <a:prstGeom prst="roundRect">
+            <a:avLst>
+              <a:gd name="adj" fmla="val 7619"/>
+            </a:avLst>
+          </a:prstGeom>
+          <a:solidFill>
+            <a:srgbClr val="141B33"/>
+          </a:solidFill>
+          <a:ln w="12700">
+            <a:solidFill>
+              <a:srgbClr val="263055"/>
+            </a:solidFill>
+            <a:prstDash val="solid"/>
+          </a:ln>
+        </p:spPr>
       </p:sp>
       <p:sp>
         <p:nvSpPr>
@@ -2688,69 +2788,60 @@
         </p:nvSpPr>
         <p:spPr>
           <a:xfrm>
-            <a:off x="4572000" y="2103120"/>
-            <a:ext cx="3108960" cy="1097280"/>
-          </a:xfrm>
-          <a:prstGeom prst="rect">
-            <a:avLst/>
-          </a:prstGeom>
-          <a:noFill/>
-          <a:ln/>
-        </p:spPr>
-        <p:txBody>
-          <a:bodyPr wrap="square" rtlCol="0" anchor="ctr"/>
-          <a:lstStyle/>
-          <a:p>
-            <a:pPr algn="ctr" indent="0" marL="0">
-              <a:buNone/>
-            </a:pPr>
-            <a:r>
-              <a:rPr lang="en-US" sz="4400" b="1" dirty="0">
-                <a:solidFill>
-                  <a:srgbClr val="6C5CE7"/>
-                </a:solidFill>
-              </a:rPr>
-              <a:t>10s</a:t>
-            </a:r>
-            <a:endParaRPr lang="en-US" sz="4400" dirty="0"/>
-          </a:p>
-        </p:txBody>
-      </p:sp>
-      <p:sp>
-        <p:nvSpPr>
-          <p:cNvPr id="6" name="Text 4"/>
-          <p:cNvSpPr/>
-          <p:nvPr/>
-        </p:nvSpPr>
-        <p:spPr>
-          <a:xfrm>
-            <a:off x="4572000" y="3383280"/>
-            <a:ext cx="3108960" cy="1097280"/>
-          </a:xfrm>
-          <a:prstGeom prst="rect">
-            <a:avLst/>
-          </a:prstGeom>
-          <a:noFill/>
-          <a:ln/>
-        </p:spPr>
-        <p:txBody>
-          <a:bodyPr wrap="square" rtlCol="0" anchor="ctr"/>
-          <a:lstStyle/>
-          <a:p>
-            <a:pPr algn="ctr" indent="0" marL="0">
-              <a:buNone/>
-            </a:pPr>
-            <a:r>
-              <a:rPr lang="en-US" sz="1400" dirty="0">
-                <a:solidFill>
-                  <a:srgbClr val="93A0C4"/>
-                </a:solidFill>
-              </a:rPr>
-              <a:t>to know what needs action</a:t>
-            </a:r>
-            <a:endParaRPr lang="en-US" sz="1400" dirty="0"/>
-          </a:p>
-        </p:txBody>
+            <a:off x="1188720" y="1691640"/>
+            <a:ext cx="9784080" cy="685800"/>
+          </a:xfrm>
+          <a:prstGeom prst="rect">
+            <a:avLst/>
+          </a:prstGeom>
+          <a:noFill/>
+          <a:ln/>
+        </p:spPr>
+        <p:txBody>
+          <a:bodyPr wrap="square" rtlCol="0" anchor="ctr"/>
+          <a:lstStyle/>
+          <a:p>
+            <a:pPr indent="0" marL="0">
+              <a:buNone/>
+            </a:pPr>
+            <a:r>
+              <a:rPr lang="en-US" sz="1500" dirty="0">
+                <a:solidFill>
+                  <a:srgbClr val="E8ECF8"/>
+                </a:solidFill>
+              </a:rPr>
+              <a:t>Compose gold-plated MCP servers (filesystem, GitHub, Slack, Postgres), never rebuild</a:t>
+            </a:r>
+            <a:endParaRPr lang="en-US" sz="1500" dirty="0"/>
+          </a:p>
+        </p:txBody>
+      </p:sp>
+      <p:sp>
+        <p:nvSpPr>
+          <p:cNvPr id="6" name="Shape 4"/>
+          <p:cNvSpPr/>
+          <p:nvPr/>
+        </p:nvSpPr>
+        <p:spPr>
+          <a:xfrm>
+            <a:off x="822960" y="2697480"/>
+            <a:ext cx="10515600" cy="960120"/>
+          </a:xfrm>
+          <a:prstGeom prst="roundRect">
+            <a:avLst>
+              <a:gd name="adj" fmla="val 7619"/>
+            </a:avLst>
+          </a:prstGeom>
+          <a:solidFill>
+            <a:srgbClr val="141B33"/>
+          </a:solidFill>
+          <a:ln w="12700">
+            <a:solidFill>
+              <a:srgbClr val="263055"/>
+            </a:solidFill>
+            <a:prstDash val="solid"/>
+          </a:ln>
+        </p:spPr>
       </p:sp>
       <p:sp>
         <p:nvSpPr>
@@ -2760,67 +2851,157 @@
         </p:nvSpPr>
         <p:spPr>
           <a:xfrm>
-            <a:off x="8229600" y="2103120"/>
-            <a:ext cx="3108960" cy="1097280"/>
-          </a:xfrm>
-          <a:prstGeom prst="rect">
-            <a:avLst/>
-          </a:prstGeom>
-          <a:noFill/>
-          <a:ln/>
-        </p:spPr>
-        <p:txBody>
-          <a:bodyPr wrap="square" rtlCol="0" anchor="ctr"/>
-          <a:lstStyle/>
-          <a:p>
-            <a:pPr algn="ctr" indent="0" marL="0">
-              <a:buNone/>
-            </a:pPr>
-            <a:r>
-              <a:rPr lang="en-US" sz="4400" b="1" dirty="0">
-                <a:solidFill>
-                  <a:srgbClr val="6C5CE7"/>
-                </a:solidFill>
-              </a:rPr>
-              <a:t>0</a:t>
-            </a:r>
-            <a:endParaRPr lang="en-US" sz="4400" dirty="0"/>
-          </a:p>
-        </p:txBody>
-      </p:sp>
-      <p:sp>
-        <p:nvSpPr>
-          <p:cNvPr id="8" name="Text 6"/>
-          <p:cNvSpPr/>
-          <p:nvPr/>
-        </p:nvSpPr>
-        <p:spPr>
-          <a:xfrm>
-            <a:off x="8229600" y="3383280"/>
-            <a:ext cx="3108960" cy="1097280"/>
-          </a:xfrm>
-          <a:prstGeom prst="rect">
-            <a:avLst/>
-          </a:prstGeom>
-          <a:noFill/>
-          <a:ln/>
-        </p:spPr>
-        <p:txBody>
-          <a:bodyPr wrap="square" rtlCol="0" anchor="ctr"/>
-          <a:lstStyle/>
-          <a:p>
-            <a:pPr algn="ctr" indent="0" marL="0">
-              <a:buNone/>
-            </a:pPr>
-            <a:r>
-              <a:rPr lang="en-US" sz="1400" dirty="0">
-                <a:solidFill>
-                  <a:srgbClr val="93A0C4"/>
-                </a:solidFill>
-              </a:rPr>
-              <a:t>actions missed after install</a:t>
-            </a:r>
-            <a:endParaRPr lang="en-US" sz="1400" dirty="0"/>
+            <a:off x="1188720" y="2834640"/>
+            <a:ext cx="9784080" cy="685800"/>
+          </a:xfrm>
+          <a:prstGeom prst="rect">
+            <a:avLst/>
+          </a:prstGeom>
+          <a:noFill/>
+          <a:ln/>
+        </p:spPr>
+        <p:txBody>
+          <a:bodyPr wrap="square" rtlCol="0" anchor="ctr"/>
+          <a:lstStyle/>
+          <a:p>
+            <a:pPr indent="0" marL="0">
+              <a:buNone/>
+            </a:pPr>
+            <a:r>
+              <a:rPr lang="en-US" sz="1500" dirty="0">
+                <a:solidFill>
+                  <a:srgbClr val="E8ECF8"/>
+                </a:solidFill>
+              </a:rPr>
+              <a:t>Typed, allow-listed tools; the policy gate sits outside the model, not in a prompt</a:t>
+            </a:r>
+            <a:endParaRPr lang="en-US" sz="1500" dirty="0"/>
+          </a:p>
+        </p:txBody>
+      </p:sp>
+      <p:sp>
+        <p:nvSpPr>
+          <p:cNvPr id="8" name="Shape 6"/>
+          <p:cNvSpPr/>
+          <p:nvPr/>
+        </p:nvSpPr>
+        <p:spPr>
+          <a:xfrm>
+            <a:off x="822960" y="3840480"/>
+            <a:ext cx="10515600" cy="960120"/>
+          </a:xfrm>
+          <a:prstGeom prst="roundRect">
+            <a:avLst>
+              <a:gd name="adj" fmla="val 7619"/>
+            </a:avLst>
+          </a:prstGeom>
+          <a:solidFill>
+            <a:srgbClr val="141B33"/>
+          </a:solidFill>
+          <a:ln w="12700">
+            <a:solidFill>
+              <a:srgbClr val="263055"/>
+            </a:solidFill>
+            <a:prstDash val="solid"/>
+          </a:ln>
+        </p:spPr>
+      </p:sp>
+      <p:sp>
+        <p:nvSpPr>
+          <p:cNvPr id="9" name="Text 7"/>
+          <p:cNvSpPr/>
+          <p:nvPr/>
+        </p:nvSpPr>
+        <p:spPr>
+          <a:xfrm>
+            <a:off x="1188720" y="3977640"/>
+            <a:ext cx="9784080" cy="685800"/>
+          </a:xfrm>
+          <a:prstGeom prst="rect">
+            <a:avLst/>
+          </a:prstGeom>
+          <a:noFill/>
+          <a:ln/>
+        </p:spPr>
+        <p:txBody>
+          <a:bodyPr wrap="square" rtlCol="0" anchor="ctr"/>
+          <a:lstStyle/>
+          <a:p>
+            <a:pPr indent="0" marL="0">
+              <a:buNone/>
+            </a:pPr>
+            <a:r>
+              <a:rPr lang="en-US" sz="1500" dirty="0">
+                <a:solidFill>
+                  <a:srgbClr val="E8ECF8"/>
+                </a:solidFill>
+              </a:rPr>
+              <a:t>Human approval at every handoff, an audit trace on every call</a:t>
+            </a:r>
+            <a:endParaRPr lang="en-US" sz="1500" dirty="0"/>
+          </a:p>
+        </p:txBody>
+      </p:sp>
+      <p:sp>
+        <p:nvSpPr>
+          <p:cNvPr id="10" name="Shape 8"/>
+          <p:cNvSpPr/>
+          <p:nvPr/>
+        </p:nvSpPr>
+        <p:spPr>
+          <a:xfrm>
+            <a:off x="822960" y="4983480"/>
+            <a:ext cx="10515600" cy="960120"/>
+          </a:xfrm>
+          <a:prstGeom prst="roundRect">
+            <a:avLst>
+              <a:gd name="adj" fmla="val 7619"/>
+            </a:avLst>
+          </a:prstGeom>
+          <a:solidFill>
+            <a:srgbClr val="141B33"/>
+          </a:solidFill>
+          <a:ln w="12700">
+            <a:solidFill>
+              <a:srgbClr val="263055"/>
+            </a:solidFill>
+            <a:prstDash val="solid"/>
+          </a:ln>
+        </p:spPr>
+      </p:sp>
+      <p:sp>
+        <p:nvSpPr>
+          <p:cNvPr id="11" name="Text 9"/>
+          <p:cNvSpPr/>
+          <p:nvPr/>
+        </p:nvSpPr>
+        <p:spPr>
+          <a:xfrm>
+            <a:off x="1188720" y="5120640"/>
+            <a:ext cx="9784080" cy="685800"/>
+          </a:xfrm>
+          <a:prstGeom prst="rect">
+            <a:avLst/>
+          </a:prstGeom>
+          <a:noFill/>
+          <a:ln/>
+        </p:spPr>
+        <p:txBody>
+          <a:bodyPr wrap="square" rtlCol="0" anchor="ctr"/>
+          <a:lstStyle/>
+          <a:p>
+            <a:pPr indent="0" marL="0">
+              <a:buNone/>
+            </a:pPr>
+            <a:r>
+              <a:rPr lang="en-US" sz="1500" dirty="0">
+                <a:solidFill>
+                  <a:srgbClr val="E8ECF8"/>
+                </a:solidFill>
+              </a:rPr>
+              <a:t>Tool poisoning is the headline attack (Invariant Labs, 1 Apr 2025): pin and scan descriptions</a:t>
+            </a:r>
+            <a:endParaRPr lang="en-US" sz="1500" dirty="0"/>
           </a:p>
         </p:txBody>
       </p:sp>
@@ -2835,6 +3016,290 @@
 <file path=ppt/slides/slide6.xml><?xml version="1.0" encoding="utf-8"?>
 <p:sld xmlns:a="http://schemas.openxmlformats.org/drawingml/2006/main" xmlns:r="http://schemas.openxmlformats.org/officeDocument/2006/relationships" xmlns:p="http://schemas.openxmlformats.org/presentationml/2006/main">
   <p:cSld name="Slide 6">
+    <p:bg>
+      <p:bgPr>
+        <a:solidFill>
+          <a:srgbClr val="0B1020"/>
+        </a:solidFill>
+      </p:bgPr>
+    </p:bg>
+    <p:spTree>
+      <p:nvGrpSpPr>
+        <p:cNvPr id="1" name=""/>
+        <p:cNvGrpSpPr/>
+        <p:nvPr/>
+      </p:nvGrpSpPr>
+      <p:grpSpPr>
+        <a:xfrm>
+          <a:off x="0" y="0"/>
+          <a:ext cx="0" cy="0"/>
+          <a:chOff x="0" y="0"/>
+          <a:chExt cx="0" cy="0"/>
+        </a:xfrm>
+      </p:grpSpPr>
+      <p:sp>
+        <p:nvSpPr>
+          <p:cNvPr id="2" name="Text 0"/>
+          <p:cNvSpPr/>
+          <p:nvPr/>
+        </p:nvSpPr>
+        <p:spPr>
+          <a:xfrm>
+            <a:off x="822960" y="457200"/>
+            <a:ext cx="5486400" cy="548640"/>
+          </a:xfrm>
+          <a:prstGeom prst="rect">
+            <a:avLst/>
+          </a:prstGeom>
+          <a:noFill/>
+          <a:ln/>
+        </p:spPr>
+        <p:txBody>
+          <a:bodyPr wrap="square" rtlCol="0" anchor="ctr"/>
+          <a:lstStyle/>
+          <a:p>
+            <a:pPr indent="0" marL="0">
+              <a:buNone/>
+            </a:pPr>
+            <a:r>
+              <a:rPr lang="en-US" sz="3000" b="1" dirty="0">
+                <a:solidFill>
+                  <a:srgbClr val="FFFFFF"/>
+                </a:solidFill>
+              </a:rPr>
+              <a:t>Impact</a:t>
+            </a:r>
+            <a:endParaRPr lang="en-US" sz="3000" dirty="0"/>
+          </a:p>
+        </p:txBody>
+      </p:sp>
+      <p:sp>
+        <p:nvSpPr>
+          <p:cNvPr id="3" name="Text 1"/>
+          <p:cNvSpPr/>
+          <p:nvPr/>
+        </p:nvSpPr>
+        <p:spPr>
+          <a:xfrm>
+            <a:off x="914400" y="2103120"/>
+            <a:ext cx="3108960" cy="1097280"/>
+          </a:xfrm>
+          <a:prstGeom prst="rect">
+            <a:avLst/>
+          </a:prstGeom>
+          <a:noFill/>
+          <a:ln/>
+        </p:spPr>
+        <p:txBody>
+          <a:bodyPr wrap="square" rtlCol="0" anchor="ctr"/>
+          <a:lstStyle/>
+          <a:p>
+            <a:pPr algn="ctr" indent="0" marL="0">
+              <a:buNone/>
+            </a:pPr>
+            <a:r>
+              <a:rPr lang="en-US" sz="4400" b="1" dirty="0">
+                <a:solidFill>
+                  <a:srgbClr val="6C5CE7"/>
+                </a:solidFill>
+              </a:rPr>
+              <a:t>1</a:t>
+            </a:r>
+            <a:endParaRPr lang="en-US" sz="4400" dirty="0"/>
+          </a:p>
+        </p:txBody>
+      </p:sp>
+      <p:sp>
+        <p:nvSpPr>
+          <p:cNvPr id="4" name="Text 2"/>
+          <p:cNvSpPr/>
+          <p:nvPr/>
+        </p:nvSpPr>
+        <p:spPr>
+          <a:xfrm>
+            <a:off x="914400" y="3383280"/>
+            <a:ext cx="3108960" cy="1097280"/>
+          </a:xfrm>
+          <a:prstGeom prst="rect">
+            <a:avLst/>
+          </a:prstGeom>
+          <a:noFill/>
+          <a:ln/>
+        </p:spPr>
+        <p:txBody>
+          <a:bodyPr wrap="square" rtlCol="0" anchor="ctr"/>
+          <a:lstStyle/>
+          <a:p>
+            <a:pPr algn="ctr" indent="0" marL="0">
+              <a:buNone/>
+            </a:pPr>
+            <a:r>
+              <a:rPr lang="en-US" sz="1400" dirty="0">
+                <a:solidFill>
+                  <a:srgbClr val="93A0C4"/>
+                </a:solidFill>
+              </a:rPr>
+              <a:t>feed replaces N channels</a:t>
+            </a:r>
+            <a:endParaRPr lang="en-US" sz="1400" dirty="0"/>
+          </a:p>
+        </p:txBody>
+      </p:sp>
+      <p:sp>
+        <p:nvSpPr>
+          <p:cNvPr id="5" name="Text 3"/>
+          <p:cNvSpPr/>
+          <p:nvPr/>
+        </p:nvSpPr>
+        <p:spPr>
+          <a:xfrm>
+            <a:off x="4572000" y="2103120"/>
+            <a:ext cx="3108960" cy="1097280"/>
+          </a:xfrm>
+          <a:prstGeom prst="rect">
+            <a:avLst/>
+          </a:prstGeom>
+          <a:noFill/>
+          <a:ln/>
+        </p:spPr>
+        <p:txBody>
+          <a:bodyPr wrap="square" rtlCol="0" anchor="ctr"/>
+          <a:lstStyle/>
+          <a:p>
+            <a:pPr algn="ctr" indent="0" marL="0">
+              <a:buNone/>
+            </a:pPr>
+            <a:r>
+              <a:rPr lang="en-US" sz="4400" b="1" dirty="0">
+                <a:solidFill>
+                  <a:srgbClr val="6C5CE7"/>
+                </a:solidFill>
+              </a:rPr>
+              <a:t>10s</a:t>
+            </a:r>
+            <a:endParaRPr lang="en-US" sz="4400" dirty="0"/>
+          </a:p>
+        </p:txBody>
+      </p:sp>
+      <p:sp>
+        <p:nvSpPr>
+          <p:cNvPr id="6" name="Text 4"/>
+          <p:cNvSpPr/>
+          <p:nvPr/>
+        </p:nvSpPr>
+        <p:spPr>
+          <a:xfrm>
+            <a:off x="4572000" y="3383280"/>
+            <a:ext cx="3108960" cy="1097280"/>
+          </a:xfrm>
+          <a:prstGeom prst="rect">
+            <a:avLst/>
+          </a:prstGeom>
+          <a:noFill/>
+          <a:ln/>
+        </p:spPr>
+        <p:txBody>
+          <a:bodyPr wrap="square" rtlCol="0" anchor="ctr"/>
+          <a:lstStyle/>
+          <a:p>
+            <a:pPr algn="ctr" indent="0" marL="0">
+              <a:buNone/>
+            </a:pPr>
+            <a:r>
+              <a:rPr lang="en-US" sz="1400" dirty="0">
+                <a:solidFill>
+                  <a:srgbClr val="93A0C4"/>
+                </a:solidFill>
+              </a:rPr>
+              <a:t>to know what needs action</a:t>
+            </a:r>
+            <a:endParaRPr lang="en-US" sz="1400" dirty="0"/>
+          </a:p>
+        </p:txBody>
+      </p:sp>
+      <p:sp>
+        <p:nvSpPr>
+          <p:cNvPr id="7" name="Text 5"/>
+          <p:cNvSpPr/>
+          <p:nvPr/>
+        </p:nvSpPr>
+        <p:spPr>
+          <a:xfrm>
+            <a:off x="8229600" y="2103120"/>
+            <a:ext cx="3108960" cy="1097280"/>
+          </a:xfrm>
+          <a:prstGeom prst="rect">
+            <a:avLst/>
+          </a:prstGeom>
+          <a:noFill/>
+          <a:ln/>
+        </p:spPr>
+        <p:txBody>
+          <a:bodyPr wrap="square" rtlCol="0" anchor="ctr"/>
+          <a:lstStyle/>
+          <a:p>
+            <a:pPr algn="ctr" indent="0" marL="0">
+              <a:buNone/>
+            </a:pPr>
+            <a:r>
+              <a:rPr lang="en-US" sz="4400" b="1" dirty="0">
+                <a:solidFill>
+                  <a:srgbClr val="6C5CE7"/>
+                </a:solidFill>
+              </a:rPr>
+              <a:t>0</a:t>
+            </a:r>
+            <a:endParaRPr lang="en-US" sz="4400" dirty="0"/>
+          </a:p>
+        </p:txBody>
+      </p:sp>
+      <p:sp>
+        <p:nvSpPr>
+          <p:cNvPr id="8" name="Text 6"/>
+          <p:cNvSpPr/>
+          <p:nvPr/>
+        </p:nvSpPr>
+        <p:spPr>
+          <a:xfrm>
+            <a:off x="8229600" y="3383280"/>
+            <a:ext cx="3108960" cy="1097280"/>
+          </a:xfrm>
+          <a:prstGeom prst="rect">
+            <a:avLst/>
+          </a:prstGeom>
+          <a:noFill/>
+          <a:ln/>
+        </p:spPr>
+        <p:txBody>
+          <a:bodyPr wrap="square" rtlCol="0" anchor="ctr"/>
+          <a:lstStyle/>
+          <a:p>
+            <a:pPr algn="ctr" indent="0" marL="0">
+              <a:buNone/>
+            </a:pPr>
+            <a:r>
+              <a:rPr lang="en-US" sz="1400" dirty="0">
+                <a:solidFill>
+                  <a:srgbClr val="93A0C4"/>
+                </a:solidFill>
+              </a:rPr>
+              <a:t>actions missed after install</a:t>
+            </a:r>
+            <a:endParaRPr lang="en-US" sz="1400" dirty="0"/>
+          </a:p>
+        </p:txBody>
+      </p:sp>
+    </p:spTree>
+  </p:cSld>
+  <p:clrMapOvr>
+    <a:masterClrMapping/>
+  </p:clrMapOvr>
+</p:sld>
+</file>
+
+<file path=ppt/slides/slide7.xml><?xml version="1.0" encoding="utf-8"?>
+<p:sld xmlns:a="http://schemas.openxmlformats.org/drawingml/2006/main" xmlns:r="http://schemas.openxmlformats.org/officeDocument/2006/relationships" xmlns:p="http://schemas.openxmlformats.org/presentationml/2006/main">
+  <p:cSld name="Slide 7">
     <p:bg>
       <p:bgPr>
         <a:solidFill>
@@ -3276,9 +3741,9 @@
 </p:sld>
 </file>
 
-<file path=ppt/slides/slide7.xml><?xml version="1.0" encoding="utf-8"?>
+<file path=ppt/slides/slide8.xml><?xml version="1.0" encoding="utf-8"?>
 <p:sld xmlns:a="http://schemas.openxmlformats.org/drawingml/2006/main" xmlns:r="http://schemas.openxmlformats.org/officeDocument/2006/relationships" xmlns:p="http://schemas.openxmlformats.org/presentationml/2006/main">
-  <p:cSld name="Slide 7">
+  <p:cSld name="Slide 8">
     <p:bg>
       <p:bgPr>
         <a:solidFill>

</xml_diff>